<commit_message>
Añadir la diapositiva de conclusiones de SCAMPER al bloque 2
Nueva diapositiva tras «No os quedéis en el primer prompt» para que
cada pareja presente su mejor idea sin IA, la mejor idea de la IA y lo
que la IA no entendió. Insertada sin modificar las demás diapositivas.
El guion recoge la puesta en común al final del tramo 62–72.

Co-Authored-By: Claude Opus 5.5 <noreply@anthropic.com>
</commit_message>
<xml_diff>
--- a/diapositivas/bloque2.pptx
+++ b/diapositivas/bloque2.pptx
@@ -13,6 +13,7 @@
     <p:sldId id="261" r:id="rId7"/>
     <p:sldId id="262" r:id="rId8"/>
     <p:sldId id="263" r:id="rId9"/>
+    <p:sldId id="275" r:id="rId26"/>
     <p:sldId id="264" r:id="rId10"/>
     <p:sldId id="265" r:id="rId11"/>
     <p:sldId id="266" r:id="rId12"/>
@@ -139,6 +140,7 @@
             <p14:sldId id="261"/>
             <p14:sldId id="262"/>
             <p14:sldId id="263"/>
+            <p14:sldId id="275"/>
           </p14:sldIdLst>
         </p14:section>
         <p14:section name="Provocación" id="{e828f01f-688f-6f94-8875-2aa07c3c65ff}">
@@ -1571,6 +1573,88 @@
         <p14:creationId xmlns:p14="http://schemas.microsoft.com/office/powerpoint/2010/main" val="1024086991"/>
       </p:ext>
     </p:extLst>
+  </p:cSld>
+  <p:clrMapOvr>
+    <a:masterClrMapping/>
+  </p:clrMapOvr>
+</p:notes>
+</file>
+
+<file path=ppt/notesSlides/notesSlide20.xml><?xml version="1.0" encoding="utf-8"?>
+<p:notes xmlns:a="http://schemas.openxmlformats.org/drawingml/2006/main" xmlns:p="http://schemas.openxmlformats.org/presentationml/2006/main" xmlns:r="http://schemas.openxmlformats.org/officeDocument/2006/relationships">
+  <p:cSld>
+    <p:spTree>
+      <p:nvGrpSpPr>
+        <p:cNvPr id="1" name=""/>
+        <p:cNvGrpSpPr/>
+        <p:nvPr/>
+      </p:nvGrpSpPr>
+      <p:grpSpPr>
+        <a:xfrm>
+          <a:off x="0" y="0"/>
+          <a:ext cx="0" cy="0"/>
+          <a:chOff x="0" y="0"/>
+          <a:chExt cx="0" cy="0"/>
+        </a:xfrm>
+      </p:grpSpPr>
+      <p:sp>
+        <p:nvSpPr>
+          <p:cNvPr id="2" name="Slide Image Placeholder 1"/>
+          <p:cNvSpPr>
+            <a:spLocks noGrp="1"/>
+          </p:cNvSpPr>
+          <p:nvPr>
+            <p:ph type="sldImg" idx="2"/>
+          </p:nvPr>
+        </p:nvSpPr>
+        <p:spPr/>
+      </p:sp>
+      <p:sp>
+        <p:nvSpPr>
+          <p:cNvPr id="3" name="Notes Placeholder 2"/>
+          <p:cNvSpPr>
+            <a:spLocks noGrp="1"/>
+          </p:cNvSpPr>
+          <p:nvPr>
+            <p:ph type="body" idx="3" sz="quarter"/>
+          </p:nvPr>
+        </p:nvSpPr>
+        <p:spPr/>
+        <p:txBody>
+          <a:bodyPr/>
+          <a:lstStyle/>
+          <a:p>
+            <a:r>
+              <a:t>Últimos minutos del tramo 62–72, antes de pasar a la provocación. Cada pareja cuenta en unos 30 segundos su mejor idea sin IA, la mejor idea que le ha dado la IA y algo que la IA no haya entendido de su caso.</a:t>
+            </a:r>
+          </a:p>
+          <a:p/>
+          <a:p>
+            <a:r>
+              <a:t>Con 8 parejas son unos 4 minutos: ir rápido, sin debatir cada idea. Si no da tiempo, que hablen solo tres o cuatro parejas.</a:t>
+            </a:r>
+          </a:p>
+          <a:p/>
+          <a:p>
+            <a:r>
+              <a:t>Al final, la pregunta para todos: ¿qué ha aportado la IA que no se os hubiera ocurrido? No adelantar la conclusión: que salga de lo que cuentan las parejas. Las ideas se guardan: se usarán en la selección de las tres propuestas.</a:t>
+            </a:r>
+          </a:p>
+        </p:txBody>
+      </p:sp>
+      <p:sp>
+        <p:nvSpPr>
+          <p:cNvPr id="4" name="Slide Number Placeholder 3"/>
+          <p:cNvSpPr>
+            <a:spLocks noGrp="1"/>
+          </p:cNvSpPr>
+          <p:nvPr>
+            <p:ph type="sldNum" idx="5" sz="quarter"/>
+          </p:nvPr>
+        </p:nvSpPr>
+        <p:spPr/>
+      </p:sp>
+    </p:spTree>
   </p:cSld>
   <p:clrMapOvr>
     <a:masterClrMapping/>
@@ -11208,6 +11292,492 @@
             <a:fld id="{F7021451-1387-4CA6-816F-3879F97B5CBC}" type="slidenum">
               <a:rPr b="0" lang="en-US"/>
               <a:t>2</a:t>
+            </a:fld>
+            <a:endParaRPr lang="en-US"/>
+          </a:p>
+        </p:txBody>
+      </p:sp>
+    </p:spTree>
+  </p:cSld>
+  <p:clrMapOvr>
+    <a:masterClrMapping/>
+  </p:clrMapOvr>
+</p:sld>
+</file>
+
+<file path=ppt/slides/slide20.xml><?xml version="1.0" encoding="utf-8"?>
+<p:sld xmlns:a="http://schemas.openxmlformats.org/drawingml/2006/main" xmlns:p="http://schemas.openxmlformats.org/presentationml/2006/main" xmlns:r="http://schemas.openxmlformats.org/officeDocument/2006/relationships">
+  <p:cSld>
+    <p:spTree>
+      <p:nvGrpSpPr>
+        <p:cNvPr id="1" name=""/>
+        <p:cNvGrpSpPr/>
+        <p:nvPr/>
+      </p:nvGrpSpPr>
+      <p:grpSpPr/>
+      <p:sp>
+        <p:nvSpPr>
+          <p:cNvPr id="2" name="Text 0"/>
+          <p:cNvSpPr/>
+          <p:nvPr>
+            <p:ph idx="100" type="title" hasCustomPrompt="1"/>
+          </p:nvPr>
+        </p:nvSpPr>
+        <p:spPr>
+          <a:xfrm>
+            <a:off x="548640" y="411480"/>
+            <a:ext cx="11094415" cy="777240"/>
+          </a:xfrm>
+          <a:prstGeom prst="rect">
+            <a:avLst/>
+          </a:prstGeom>
+          <a:noFill/>
+          <a:ln/>
+        </p:spPr>
+        <p:txBody>
+          <a:bodyPr wrap="square" lIns="0" tIns="0" rIns="0" bIns="0" rtlCol="0" anchor="ctr"/>
+          <a:lstStyle/>
+          <a:p>
+            <a:pPr algn="l" indent="0" marL="0">
+              <a:buNone/>
+            </a:pPr>
+            <a:r>
+              <a:rPr lang="en-US" sz="3200" b="1" dirty="0">
+                <a:solidFill>
+                  <a:schemeClr val="tx1"/>
+                </a:solidFill>
+              </a:rPr>
+              <a:t>Conclusiones de SCAMPER</a:t>
+            </a:r>
+            <a:endParaRPr lang="en-US" sz="3200" dirty="0"/>
+          </a:p>
+        </p:txBody>
+      </p:sp>
+      <p:sp>
+        <p:nvSpPr>
+          <p:cNvPr id="3" name="Etiqueta de tiempo"/>
+          <p:cNvSpPr/>
+          <p:nvPr/>
+        </p:nvSpPr>
+        <p:spPr>
+          <a:xfrm>
+            <a:off x="9082735" y="548640"/>
+            <a:ext cx="2560320" cy="457200"/>
+          </a:xfrm>
+          <a:prstGeom prst="roundRect">
+            <a:avLst>
+              <a:gd name="adj" fmla="val 50000"/>
+            </a:avLst>
+          </a:prstGeom>
+          <a:solidFill>
+            <a:schemeClr val="accent1"/>
+          </a:solidFill>
+          <a:ln/>
+        </p:spPr>
+      </p:sp>
+      <p:sp>
+        <p:nvSpPr>
+          <p:cNvPr id="4" name="Text 2"/>
+          <p:cNvSpPr txBox="1"/>
+          <p:nvPr/>
+        </p:nvSpPr>
+        <p:spPr>
+          <a:xfrm>
+            <a:off x="9082735" y="548640"/>
+            <a:ext cx="2560320" cy="457200"/>
+          </a:xfrm>
+          <a:prstGeom prst="rect">
+            <a:avLst/>
+          </a:prstGeom>
+          <a:noFill/>
+          <a:ln/>
+        </p:spPr>
+        <p:txBody>
+          <a:bodyPr wrap="square" lIns="0" tIns="0" rIns="0" bIns="0" rtlCol="0" anchor="ctr"/>
+          <a:lstStyle/>
+          <a:p>
+            <a:pPr algn="ctr" indent="0" marL="0">
+              <a:buNone/>
+            </a:pPr>
+            <a:r>
+              <a:rPr lang="en-US" sz="1400" b="1" dirty="0">
+                <a:solidFill>
+                  <a:schemeClr val="tx1"/>
+                </a:solidFill>
+              </a:rPr>
+              <a:t>Min. 62–72 · Parejas</a:t>
+            </a:r>
+            <a:endParaRPr lang="en-US" sz="1400" dirty="0"/>
+          </a:p>
+        </p:txBody>
+      </p:sp>
+      <p:sp>
+        <p:nvSpPr>
+          <p:cNvPr id="5" name="Text 3"/>
+          <p:cNvSpPr txBox="1"/>
+          <p:nvPr/>
+        </p:nvSpPr>
+        <p:spPr>
+          <a:xfrm>
+            <a:off x="548640" y="1325880"/>
+            <a:ext cx="11094415" cy="548640"/>
+          </a:xfrm>
+          <a:prstGeom prst="rect">
+            <a:avLst/>
+          </a:prstGeom>
+          <a:noFill/>
+          <a:ln/>
+        </p:spPr>
+        <p:txBody>
+          <a:bodyPr wrap="square" lIns="0" tIns="0" rIns="0" bIns="0" rtlCol="0" anchor="ctr"/>
+          <a:lstStyle/>
+          <a:p>
+            <a:pPr indent="0" marL="0">
+              <a:buNone/>
+            </a:pPr>
+            <a:r>
+              <a:rPr lang="en-US" sz="1900" dirty="0">
+                <a:solidFill>
+                  <a:schemeClr val="tx2"/>
+                </a:solidFill>
+              </a:rPr>
+              <a:t>Cada pareja cuenta en 30 segundos lo que ha sacado de SCAMPER:</a:t>
+            </a:r>
+            <a:endParaRPr lang="en-US" sz="1900" dirty="0"/>
+          </a:p>
+        </p:txBody>
+      </p:sp>
+      <p:sp>
+        <p:nvSpPr>
+          <p:cNvPr id="22" name="Idea práctica"/>
+          <p:cNvSpPr/>
+          <p:nvPr/>
+        </p:nvSpPr>
+        <p:spPr>
+          <a:xfrm>
+            <a:off x="548640" y="2057400"/>
+            <a:ext cx="3454298" cy="548640"/>
+          </a:xfrm>
+          <a:prstGeom prst="roundRect">
+            <a:avLst>
+              <a:gd name="adj" fmla="val 16667"/>
+            </a:avLst>
+          </a:prstGeom>
+          <a:solidFill>
+            <a:schemeClr val="accent1"/>
+          </a:solidFill>
+          <a:ln/>
+        </p:spPr>
+      </p:sp>
+      <p:sp>
+        <p:nvSpPr>
+          <p:cNvPr id="23" name="Text 21"/>
+          <p:cNvSpPr txBox="1"/>
+          <p:nvPr/>
+        </p:nvSpPr>
+        <p:spPr>
+          <a:xfrm>
+            <a:off x="548640" y="2057400"/>
+            <a:ext cx="3454298" cy="548640"/>
+          </a:xfrm>
+          <a:prstGeom prst="rect">
+            <a:avLst/>
+          </a:prstGeom>
+          <a:noFill/>
+          <a:ln/>
+        </p:spPr>
+        <p:txBody>
+          <a:bodyPr wrap="square" lIns="0" tIns="0" rIns="0" bIns="0" rtlCol="0" anchor="ctr"/>
+          <a:lstStyle/>
+          <a:p>
+            <a:pPr algn="ctr" indent="0" marL="0">
+              <a:buNone/>
+            </a:pPr>
+            <a:r>
+              <a:rPr lang="en-US" sz="1800" b="1" dirty="0">
+                <a:solidFill>
+                  <a:schemeClr val="tx1"/>
+                </a:solidFill>
+              </a:rPr>
+              <a:t>Nuestra mejor idea sin IA</a:t>
+            </a:r>
+            <a:endParaRPr lang="en-US" sz="1800" dirty="0"/>
+          </a:p>
+        </p:txBody>
+      </p:sp>
+      <p:sp>
+        <p:nvSpPr>
+          <p:cNvPr id="8" name="Hueco"/>
+          <p:cNvSpPr/>
+          <p:nvPr/>
+        </p:nvSpPr>
+        <p:spPr>
+          <a:xfrm>
+            <a:off x="548640" y="2788920"/>
+            <a:ext cx="3454298" cy="2423160"/>
+          </a:xfrm>
+          <a:prstGeom prst="roundRect">
+            <a:avLst>
+              <a:gd name="adj" fmla="val 10526"/>
+            </a:avLst>
+          </a:prstGeom>
+          <a:solidFill>
+            <a:schemeClr val="bg2"/>
+          </a:solidFill>
+          <a:ln w="12700">
+            <a:solidFill>
+              <a:srgbClr val="8A94A6"/>
+            </a:solidFill>
+            <a:prstDash val="dash"/>
+          </a:ln>
+        </p:spPr>
+      </p:sp>
+      <p:sp>
+        <p:nvSpPr>
+          <p:cNvPr id="14" name="Principio útil"/>
+          <p:cNvSpPr/>
+          <p:nvPr/>
+        </p:nvSpPr>
+        <p:spPr>
+          <a:xfrm>
+            <a:off x="4368698" y="2057400"/>
+            <a:ext cx="3454298" cy="548640"/>
+          </a:xfrm>
+          <a:prstGeom prst="roundRect">
+            <a:avLst>
+              <a:gd name="adj" fmla="val 16667"/>
+            </a:avLst>
+          </a:prstGeom>
+          <a:solidFill>
+            <a:schemeClr val="accent2"/>
+          </a:solidFill>
+          <a:ln/>
+        </p:spPr>
+      </p:sp>
+      <p:sp>
+        <p:nvSpPr>
+          <p:cNvPr id="15" name="Text 13"/>
+          <p:cNvSpPr txBox="1"/>
+          <p:nvPr/>
+        </p:nvSpPr>
+        <p:spPr>
+          <a:xfrm>
+            <a:off x="4368698" y="2057400"/>
+            <a:ext cx="3454298" cy="548640"/>
+          </a:xfrm>
+          <a:prstGeom prst="rect">
+            <a:avLst/>
+          </a:prstGeom>
+          <a:noFill/>
+          <a:ln/>
+        </p:spPr>
+        <p:txBody>
+          <a:bodyPr wrap="square" lIns="0" tIns="0" rIns="0" bIns="0" rtlCol="0" anchor="ctr"/>
+          <a:lstStyle/>
+          <a:p>
+            <a:pPr algn="ctr" indent="0" marL="0">
+              <a:buNone/>
+            </a:pPr>
+            <a:r>
+              <a:rPr lang="en-US" sz="1800" b="1" dirty="0">
+                <a:solidFill>
+                  <a:schemeClr val="bg1"/>
+                </a:solidFill>
+              </a:rPr>
+              <a:t>La mejor idea de la IA</a:t>
+            </a:r>
+            <a:endParaRPr lang="en-US" sz="1800" dirty="0"/>
+          </a:p>
+        </p:txBody>
+      </p:sp>
+      <p:sp>
+        <p:nvSpPr>
+          <p:cNvPr id="8" name="Hueco"/>
+          <p:cNvSpPr/>
+          <p:nvPr/>
+        </p:nvSpPr>
+        <p:spPr>
+          <a:xfrm>
+            <a:off x="4368698" y="2788920"/>
+            <a:ext cx="3454298" cy="2423160"/>
+          </a:xfrm>
+          <a:prstGeom prst="roundRect">
+            <a:avLst>
+              <a:gd name="adj" fmla="val 10526"/>
+            </a:avLst>
+          </a:prstGeom>
+          <a:solidFill>
+            <a:schemeClr val="bg2"/>
+          </a:solidFill>
+          <a:ln w="12700">
+            <a:solidFill>
+              <a:srgbClr val="8A94A6"/>
+            </a:solidFill>
+            <a:prstDash val="dash"/>
+          </a:ln>
+        </p:spPr>
+      </p:sp>
+      <p:sp>
+        <p:nvSpPr>
+          <p:cNvPr id="6" name="Provocación"/>
+          <p:cNvSpPr/>
+          <p:nvPr/>
+        </p:nvSpPr>
+        <p:spPr>
+          <a:xfrm>
+            <a:off x="8188756" y="2057400"/>
+            <a:ext cx="3454298" cy="548640"/>
+          </a:xfrm>
+          <a:prstGeom prst="roundRect">
+            <a:avLst>
+              <a:gd name="adj" fmla="val 16667"/>
+            </a:avLst>
+          </a:prstGeom>
+          <a:solidFill>
+            <a:schemeClr val="accent3"/>
+          </a:solidFill>
+          <a:ln/>
+        </p:spPr>
+      </p:sp>
+      <p:sp>
+        <p:nvSpPr>
+          <p:cNvPr id="7" name="Text 5"/>
+          <p:cNvSpPr txBox="1"/>
+          <p:nvPr/>
+        </p:nvSpPr>
+        <p:spPr>
+          <a:xfrm>
+            <a:off x="8188756" y="2057400"/>
+            <a:ext cx="3454298" cy="548640"/>
+          </a:xfrm>
+          <a:prstGeom prst="rect">
+            <a:avLst/>
+          </a:prstGeom>
+          <a:noFill/>
+          <a:ln/>
+        </p:spPr>
+        <p:txBody>
+          <a:bodyPr wrap="square" lIns="0" tIns="0" rIns="0" bIns="0" rtlCol="0" anchor="ctr"/>
+          <a:lstStyle/>
+          <a:p>
+            <a:pPr algn="ctr" indent="0" marL="0">
+              <a:buNone/>
+            </a:pPr>
+            <a:r>
+              <a:rPr lang="en-US" sz="1800" b="1" dirty="0">
+                <a:solidFill>
+                  <a:schemeClr val="bg1"/>
+                </a:solidFill>
+              </a:rPr>
+              <a:t>Lo que la IA no entendió</a:t>
+            </a:r>
+            <a:endParaRPr lang="en-US" sz="1800" dirty="0"/>
+          </a:p>
+        </p:txBody>
+      </p:sp>
+      <p:sp>
+        <p:nvSpPr>
+          <p:cNvPr id="8" name="Hueco"/>
+          <p:cNvSpPr/>
+          <p:nvPr/>
+        </p:nvSpPr>
+        <p:spPr>
+          <a:xfrm>
+            <a:off x="8188756" y="2788920"/>
+            <a:ext cx="3454298" cy="2423160"/>
+          </a:xfrm>
+          <a:prstGeom prst="roundRect">
+            <a:avLst>
+              <a:gd name="adj" fmla="val 10526"/>
+            </a:avLst>
+          </a:prstGeom>
+          <a:solidFill>
+            <a:schemeClr val="bg2"/>
+          </a:solidFill>
+          <a:ln w="12700">
+            <a:solidFill>
+              <a:srgbClr val="8A94A6"/>
+            </a:solidFill>
+            <a:prstDash val="dash"/>
+          </a:ln>
+        </p:spPr>
+      </p:sp>
+      <p:sp>
+        <p:nvSpPr>
+          <p:cNvPr id="5" name="Text 3"/>
+          <p:cNvSpPr txBox="1"/>
+          <p:nvPr/>
+        </p:nvSpPr>
+        <p:spPr>
+          <a:xfrm>
+            <a:off x="548640" y="5440680"/>
+            <a:ext cx="11094415" cy="548640"/>
+          </a:xfrm>
+          <a:prstGeom prst="rect">
+            <a:avLst/>
+          </a:prstGeom>
+          <a:noFill/>
+          <a:ln/>
+        </p:spPr>
+        <p:txBody>
+          <a:bodyPr wrap="square" lIns="0" tIns="0" rIns="0" bIns="0" rtlCol="0" anchor="ctr"/>
+          <a:lstStyle/>
+          <a:p>
+            <a:pPr indent="0" marL="0">
+              <a:buNone/>
+            </a:pPr>
+            <a:r>
+              <a:rPr lang="en-US" sz="1900" dirty="0">
+                <a:solidFill>
+                  <a:schemeClr val="tx2"/>
+                </a:solidFill>
+              </a:rPr>
+              <a:t>Para todos: ¿qué ha aportado la IA que no se os hubiera ocurrido? ¿Y qué no ha entendido de vuestro caso?</a:t>
+            </a:r>
+            <a:endParaRPr lang="en-US" sz="1900" dirty="0"/>
+          </a:p>
+        </p:txBody>
+      </p:sp>
+      <p:sp>
+        <p:nvSpPr>
+          <p:cNvPr id="25" name="Slide Number Placeholder 0"/>
+          <p:cNvSpPr>
+            <a:spLocks noGrp="1"/>
+          </p:cNvSpPr>
+          <p:nvPr>
+            <p:ph type="sldNum" sz="quarter" idx="4294967295"/>
+          </p:nvPr>
+        </p:nvSpPr>
+        <p:spPr>
+          <a:xfrm>
+            <a:off x="11091672" y="6355080"/>
+            <a:ext cx="548640" cy="320040"/>
+          </a:xfrm>
+          <a:prstGeom prst="rect">
+            <a:avLst/>
+          </a:prstGeom>
+          <a:extLst>
+            <a:ext uri="{C572A759-6A51-4108-AA02-DFA0A04FC94B}">
+              <ma14:wrappingTextBoxFlag xmlns:ma14="http://schemas.microsoft.com/office/mac/drawingml/2011/main" val="0"/>
+            </a:ext>
+          </a:extLst>
+        </p:spPr>
+        <p:txBody>
+          <a:bodyPr/>
+          <a:lstStyle>
+            <a:lvl1pPr>
+              <a:defRPr sz="1100">
+                <a:solidFill>
+                  <a:srgbClr val="8A94A6"/>
+                </a:solidFill>
+              </a:defRPr>
+            </a:lvl1pPr>
+          </a:lstStyle>
+          <a:p>
+            <a:pPr algn="r"/>
+            <a:fld id="{F7021451-1387-4CA6-816F-3879F97B5CBC}" type="slidenum">
+              <a:rPr b="0" lang="en-US"/>
+              <a:t>12</a:t>
             </a:fld>
             <a:endParaRPr lang="en-US"/>
           </a:p>

</xml_diff>